<commit_message>
metadata, aec 데이터 정리
</commit_message>
<xml_diff>
--- a/연구자료/260519_TotalSegmentator_Result.pptx
+++ b/연구자료/260519_TotalSegmentator_Result.pptx
@@ -5,31 +5,32 @@
     <p:sldMasterId id="2147483648" r:id="rId1"/>
   </p:sldMasterIdLst>
   <p:notesMasterIdLst>
-    <p:notesMasterId r:id="rId8"/>
+    <p:notesMasterId r:id="rId9"/>
   </p:notesMasterIdLst>
   <p:sldIdLst>
     <p:sldId id="256" r:id="rId2"/>
     <p:sldId id="551" r:id="rId3"/>
-    <p:sldId id="554" r:id="rId4"/>
-    <p:sldId id="552" r:id="rId5"/>
-    <p:sldId id="553" r:id="rId6"/>
-    <p:sldId id="479" r:id="rId7"/>
+    <p:sldId id="555" r:id="rId4"/>
+    <p:sldId id="554" r:id="rId5"/>
+    <p:sldId id="552" r:id="rId6"/>
+    <p:sldId id="553" r:id="rId7"/>
+    <p:sldId id="479" r:id="rId8"/>
   </p:sldIdLst>
   <p:sldSz cx="12192000" cy="6858000"/>
   <p:notesSz cx="6858000" cy="9144000"/>
   <p:embeddedFontLst>
     <p:embeddedFont>
       <p:font typeface="KoPub돋움체 Bold" panose="00000800000000000000" pitchFamily="2" charset="-127"/>
-      <p:bold r:id="rId9"/>
+      <p:bold r:id="rId10"/>
     </p:embeddedFont>
     <p:embeddedFont>
       <p:font typeface="KoPub돋움체 Medium" panose="00000600000000000000" pitchFamily="2" charset="-127"/>
-      <p:regular r:id="rId10"/>
+      <p:regular r:id="rId11"/>
     </p:embeddedFont>
     <p:embeddedFont>
       <p:font typeface="맑은 고딕" panose="020B0503020000020004" pitchFamily="50" charset="-127"/>
-      <p:regular r:id="rId11"/>
-      <p:bold r:id="rId12"/>
+      <p:regular r:id="rId12"/>
+      <p:bold r:id="rId13"/>
     </p:embeddedFont>
   </p:embeddedFontLst>
   <p:defaultTextStyle>
@@ -134,6 +135,7 @@
           <p14:sldIdLst>
             <p14:sldId id="256"/>
             <p14:sldId id="551"/>
+            <p14:sldId id="555"/>
             <p14:sldId id="554"/>
             <p14:sldId id="552"/>
             <p14:sldId id="553"/>
@@ -260,7 +262,7 @@
             <a:fld id="{33074436-1BEA-4F09-AD5C-9DF87C96BF5A}" type="datetimeFigureOut">
               <a:rPr lang="ko-KR" altLang="en-US" smtClean="0"/>
               <a:pPr/>
-              <a:t>2026-05-18</a:t>
+              <a:t>2026-05-19</a:t>
             </a:fld>
             <a:endParaRPr lang="ko-KR" altLang="en-US" dirty="0"/>
           </a:p>
@@ -714,6 +716,114 @@
         <p:cNvPr id="1" name="">
           <a:extLst>
             <a:ext uri="{FF2B5EF4-FFF2-40B4-BE49-F238E27FC236}">
+              <a16:creationId xmlns:a16="http://schemas.microsoft.com/office/drawing/2014/main" id="{53A7CAAC-A43F-15F6-F38E-F4B14F21180F}"/>
+            </a:ext>
+          </a:extLst>
+        </p:cNvPr>
+        <p:cNvGrpSpPr/>
+        <p:nvPr/>
+      </p:nvGrpSpPr>
+      <p:grpSpPr>
+        <a:xfrm>
+          <a:off x="0" y="0"/>
+          <a:ext cx="0" cy="0"/>
+          <a:chOff x="0" y="0"/>
+          <a:chExt cx="0" cy="0"/>
+        </a:xfrm>
+      </p:grpSpPr>
+      <p:sp>
+        <p:nvSpPr>
+          <p:cNvPr id="2" name="슬라이드 이미지 개체 틀 1">
+            <a:extLst>
+              <a:ext uri="{FF2B5EF4-FFF2-40B4-BE49-F238E27FC236}">
+                <a16:creationId xmlns:a16="http://schemas.microsoft.com/office/drawing/2014/main" id="{2CB3547B-80AA-6D0D-79FA-1FCDF983FA19}"/>
+              </a:ext>
+            </a:extLst>
+          </p:cNvPr>
+          <p:cNvSpPr>
+            <a:spLocks noGrp="1" noRot="1" noChangeAspect="1"/>
+          </p:cNvSpPr>
+          <p:nvPr>
+            <p:ph type="sldImg"/>
+          </p:nvPr>
+        </p:nvSpPr>
+        <p:spPr/>
+      </p:sp>
+      <p:sp>
+        <p:nvSpPr>
+          <p:cNvPr id="3" name="슬라이드 노트 개체 틀 2">
+            <a:extLst>
+              <a:ext uri="{FF2B5EF4-FFF2-40B4-BE49-F238E27FC236}">
+                <a16:creationId xmlns:a16="http://schemas.microsoft.com/office/drawing/2014/main" id="{9AF9C7F7-4ABD-CFF8-3ED4-082C306DF167}"/>
+              </a:ext>
+            </a:extLst>
+          </p:cNvPr>
+          <p:cNvSpPr>
+            <a:spLocks noGrp="1"/>
+          </p:cNvSpPr>
+          <p:nvPr>
+            <p:ph type="body" idx="1"/>
+          </p:nvPr>
+        </p:nvSpPr>
+        <p:spPr/>
+        <p:txBody>
+          <a:bodyPr/>
+          <a:lstStyle/>
+          <a:p>
+            <a:endParaRPr lang="en-US" altLang="ko-KR" dirty="0"/>
+          </a:p>
+        </p:txBody>
+      </p:sp>
+      <p:sp>
+        <p:nvSpPr>
+          <p:cNvPr id="4" name="슬라이드 번호 개체 틀 3">
+            <a:extLst>
+              <a:ext uri="{FF2B5EF4-FFF2-40B4-BE49-F238E27FC236}">
+                <a16:creationId xmlns:a16="http://schemas.microsoft.com/office/drawing/2014/main" id="{0D17007A-A9B5-A594-7165-EBA1B58F6615}"/>
+              </a:ext>
+            </a:extLst>
+          </p:cNvPr>
+          <p:cNvSpPr>
+            <a:spLocks noGrp="1"/>
+          </p:cNvSpPr>
+          <p:nvPr>
+            <p:ph type="sldNum" sz="quarter" idx="5"/>
+          </p:nvPr>
+        </p:nvSpPr>
+        <p:spPr/>
+        <p:txBody>
+          <a:bodyPr/>
+          <a:lstStyle/>
+          <a:p>
+            <a:fld id="{433C9518-700F-4811-95BB-24DAF3FA92F2}" type="slidenum">
+              <a:rPr lang="ko-KR" altLang="en-US" smtClean="0"/>
+              <a:t>3</a:t>
+            </a:fld>
+            <a:endParaRPr lang="ko-KR" altLang="en-US"/>
+          </a:p>
+        </p:txBody>
+      </p:sp>
+    </p:spTree>
+    <p:extLst>
+      <p:ext uri="{BB962C8B-B14F-4D97-AF65-F5344CB8AC3E}">
+        <p14:creationId xmlns:p14="http://schemas.microsoft.com/office/powerpoint/2010/main" val="3103059840"/>
+      </p:ext>
+    </p:extLst>
+  </p:cSld>
+  <p:clrMapOvr>
+    <a:masterClrMapping/>
+  </p:clrMapOvr>
+</p:notes>
+</file>
+
+<file path=ppt/notesSlides/notesSlide4.xml><?xml version="1.0" encoding="utf-8"?>
+<p:notes xmlns:a="http://schemas.openxmlformats.org/drawingml/2006/main" xmlns:r="http://schemas.openxmlformats.org/officeDocument/2006/relationships" xmlns:p="http://schemas.openxmlformats.org/presentationml/2006/main">
+  <p:cSld>
+    <p:spTree>
+      <p:nvGrpSpPr>
+        <p:cNvPr id="1" name="">
+          <a:extLst>
+            <a:ext uri="{FF2B5EF4-FFF2-40B4-BE49-F238E27FC236}">
               <a16:creationId xmlns:a16="http://schemas.microsoft.com/office/drawing/2014/main" id="{4B704183-5D94-C9AF-55C7-FE0777799133}"/>
             </a:ext>
           </a:extLst>
@@ -795,7 +905,7 @@
           <a:p>
             <a:fld id="{433C9518-700F-4811-95BB-24DAF3FA92F2}" type="slidenum">
               <a:rPr lang="ko-KR" altLang="en-US" smtClean="0"/>
-              <a:t>4</a:t>
+              <a:t>5</a:t>
             </a:fld>
             <a:endParaRPr lang="ko-KR" altLang="en-US"/>
           </a:p>
@@ -814,7 +924,7 @@
 </p:notes>
 </file>
 
-<file path=ppt/notesSlides/notesSlide4.xml><?xml version="1.0" encoding="utf-8"?>
+<file path=ppt/notesSlides/notesSlide5.xml><?xml version="1.0" encoding="utf-8"?>
 <p:notes xmlns:a="http://schemas.openxmlformats.org/drawingml/2006/main" xmlns:r="http://schemas.openxmlformats.org/officeDocument/2006/relationships" xmlns:p="http://schemas.openxmlformats.org/presentationml/2006/main" showMasterSp="0" showMasterPhAnim="0">
   <p:cSld>
     <p:spTree>
@@ -951,7 +1061,7 @@
             </a:pPr>
             <a:fld id="{00000000-1234-1234-1234-123412341234}" type="slidenum">
               <a:rPr lang="en-US"/>
-              <a:t>6</a:t>
+              <a:t>7</a:t>
             </a:fld>
             <a:endParaRPr/>
           </a:p>
@@ -4812,25 +4922,241 @@
           </a:p>
         </p:txBody>
       </p:sp>
+      <p:sp>
+        <p:nvSpPr>
+          <p:cNvPr id="7" name="내용 개체 틀 2">
+            <a:extLst>
+              <a:ext uri="{FF2B5EF4-FFF2-40B4-BE49-F238E27FC236}">
+                <a16:creationId xmlns:a16="http://schemas.microsoft.com/office/drawing/2014/main" id="{1085DB8A-F2FD-AB70-F0B6-F5E8612C16E3}"/>
+              </a:ext>
+            </a:extLst>
+          </p:cNvPr>
+          <p:cNvSpPr>
+            <a:spLocks noGrp="1"/>
+          </p:cNvSpPr>
+          <p:nvPr>
+            <p:ph idx="1"/>
+          </p:nvPr>
+        </p:nvSpPr>
+        <p:spPr>
+          <a:xfrm>
+            <a:off x="508000" y="897468"/>
+            <a:ext cx="11176000" cy="5063066"/>
+          </a:xfrm>
+        </p:spPr>
+        <p:txBody>
+          <a:bodyPr/>
+          <a:lstStyle/>
+          <a:p>
+            <a:r>
+              <a:rPr lang="en-US" altLang="ko-KR" dirty="0"/>
+              <a:t>Data </a:t>
+            </a:r>
+            <a:r>
+              <a:rPr lang="ko-KR" altLang="en-US" dirty="0"/>
+              <a:t>정리</a:t>
+            </a:r>
+            <a:endParaRPr lang="en-US" altLang="ko-KR" dirty="0"/>
+          </a:p>
+          <a:p>
+            <a:pPr lvl="1"/>
+            <a:r>
+              <a:rPr lang="en-US" altLang="ko-KR" dirty="0" err="1"/>
+              <a:t>MetaData</a:t>
+            </a:r>
+            <a:endParaRPr lang="en-US" altLang="ko-KR" dirty="0"/>
+          </a:p>
+          <a:p>
+            <a:pPr lvl="1"/>
+            <a:r>
+              <a:rPr lang="en-US" altLang="ko-KR" dirty="0"/>
+              <a:t>Patient 3,762 </a:t>
+            </a:r>
+            <a:r>
+              <a:rPr lang="ko-KR" altLang="en-US" dirty="0"/>
+              <a:t>→ 중복 제거 </a:t>
+            </a:r>
+            <a:r>
+              <a:rPr lang="en-US" altLang="ko-KR" dirty="0"/>
+              <a:t>2,033</a:t>
+            </a:r>
+          </a:p>
+          <a:p>
+            <a:pPr lvl="1"/>
+            <a:endParaRPr lang="en-US" altLang="ko-KR" dirty="0"/>
+          </a:p>
+          <a:p>
+            <a:pPr lvl="1"/>
+            <a:endParaRPr lang="en-US" altLang="ko-KR" dirty="0"/>
+          </a:p>
+          <a:p>
+            <a:pPr lvl="1"/>
+            <a:r>
+              <a:rPr lang="en-US" altLang="ko-KR" dirty="0"/>
+              <a:t>AEC</a:t>
+            </a:r>
+          </a:p>
+          <a:p>
+            <a:pPr lvl="1"/>
+            <a:r>
+              <a:rPr lang="en-US" altLang="ko-KR" dirty="0"/>
+              <a:t>Patient 2,054 </a:t>
+            </a:r>
+            <a:r>
+              <a:rPr lang="ko-KR" altLang="en-US" dirty="0"/>
+              <a:t>→ 상하단 기준으로 </a:t>
+            </a:r>
+            <a:r>
+              <a:rPr lang="en-US" altLang="ko-KR" dirty="0"/>
+              <a:t>Crop [T12, pubis] </a:t>
+            </a:r>
+            <a:r>
+              <a:rPr lang="ko-KR" altLang="en-US" dirty="0"/>
+              <a:t>→ </a:t>
+            </a:r>
+            <a:r>
+              <a:rPr lang="en-US" altLang="ko-KR" dirty="0" err="1"/>
+              <a:t>aec_raw</a:t>
+            </a:r>
+            <a:r>
+              <a:rPr lang="en-US" altLang="ko-KR" dirty="0"/>
+              <a:t> </a:t>
+            </a:r>
+            <a:r>
+              <a:rPr lang="ko-KR" altLang="en-US" dirty="0"/>
+              <a:t>→ </a:t>
+            </a:r>
+            <a:r>
+              <a:rPr lang="en-US" altLang="ko-KR" dirty="0"/>
+              <a:t>aec_128 </a:t>
+            </a:r>
+            <a:r>
+              <a:rPr lang="ko-KR" altLang="en-US" dirty="0"/>
+              <a:t>→ </a:t>
+            </a:r>
+            <a:r>
+              <a:rPr lang="ko-KR" altLang="en-US" dirty="0" err="1"/>
+              <a:t>고정값</a:t>
+            </a:r>
+            <a:r>
+              <a:rPr lang="ko-KR" altLang="en-US" dirty="0"/>
+              <a:t> 제거 </a:t>
+            </a:r>
+            <a:r>
+              <a:rPr lang="en-US" altLang="ko-KR"/>
+              <a:t>(1220/1287)</a:t>
+            </a:r>
+            <a:endParaRPr lang="en-US" altLang="ko-KR" dirty="0"/>
+          </a:p>
+        </p:txBody>
+      </p:sp>
+    </p:spTree>
+    <p:extLst>
+      <p:ext uri="{BB962C8B-B14F-4D97-AF65-F5344CB8AC3E}">
+        <p14:creationId xmlns:p14="http://schemas.microsoft.com/office/powerpoint/2010/main" val="217966962"/>
+      </p:ext>
+    </p:extLst>
+  </p:cSld>
+  <p:clrMapOvr>
+    <a:masterClrMapping/>
+  </p:clrMapOvr>
+</p:sld>
+</file>
+
+<file path=ppt/slides/slide3.xml><?xml version="1.0" encoding="utf-8"?>
+<p:sld xmlns:a="http://schemas.openxmlformats.org/drawingml/2006/main" xmlns:r="http://schemas.openxmlformats.org/officeDocument/2006/relationships" xmlns:p="http://schemas.openxmlformats.org/presentationml/2006/main">
+  <p:cSld>
+    <p:spTree>
+      <p:nvGrpSpPr>
+        <p:cNvPr id="1" name="">
+          <a:extLst>
+            <a:ext uri="{FF2B5EF4-FFF2-40B4-BE49-F238E27FC236}">
+              <a16:creationId xmlns:a16="http://schemas.microsoft.com/office/drawing/2014/main" id="{D391C564-C4E3-C7E5-176D-3C71C0D4C230}"/>
+            </a:ext>
+          </a:extLst>
+        </p:cNvPr>
+        <p:cNvGrpSpPr/>
+        <p:nvPr/>
+      </p:nvGrpSpPr>
+      <p:grpSpPr>
+        <a:xfrm>
+          <a:off x="0" y="0"/>
+          <a:ext cx="0" cy="0"/>
+          <a:chOff x="0" y="0"/>
+          <a:chExt cx="0" cy="0"/>
+        </a:xfrm>
+      </p:grpSpPr>
+      <p:sp>
+        <p:nvSpPr>
+          <p:cNvPr id="2" name="제목 1">
+            <a:extLst>
+              <a:ext uri="{FF2B5EF4-FFF2-40B4-BE49-F238E27FC236}">
+                <a16:creationId xmlns:a16="http://schemas.microsoft.com/office/drawing/2014/main" id="{F8C90F66-DE53-7F78-BD26-F25903C36DD4}"/>
+              </a:ext>
+            </a:extLst>
+          </p:cNvPr>
+          <p:cNvSpPr>
+            <a:spLocks noGrp="1"/>
+          </p:cNvSpPr>
+          <p:nvPr>
+            <p:ph type="title"/>
+          </p:nvPr>
+        </p:nvSpPr>
+        <p:spPr/>
+        <p:txBody>
+          <a:bodyPr/>
+          <a:lstStyle/>
+          <a:p>
+            <a:r>
+              <a:rPr lang="en-US" altLang="ko-KR" dirty="0"/>
+              <a:t>Detailed progress</a:t>
+            </a:r>
+            <a:endParaRPr lang="ko-KR" altLang="en-US" dirty="0"/>
+          </a:p>
+        </p:txBody>
+      </p:sp>
+      <p:sp>
+        <p:nvSpPr>
+          <p:cNvPr id="4" name="슬라이드 번호 개체 틀 3">
+            <a:extLst>
+              <a:ext uri="{FF2B5EF4-FFF2-40B4-BE49-F238E27FC236}">
+                <a16:creationId xmlns:a16="http://schemas.microsoft.com/office/drawing/2014/main" id="{DF651BCC-0290-4B0F-F77B-B861A8312C2E}"/>
+              </a:ext>
+            </a:extLst>
+          </p:cNvPr>
+          <p:cNvSpPr>
+            <a:spLocks noGrp="1"/>
+          </p:cNvSpPr>
+          <p:nvPr>
+            <p:ph type="sldNum" sz="quarter" idx="12"/>
+          </p:nvPr>
+        </p:nvSpPr>
+        <p:spPr/>
+        <p:txBody>
+          <a:bodyPr/>
+          <a:lstStyle/>
+          <a:p>
+            <a:fld id="{9F4AF89A-28FA-47FA-B28F-9A9C6913CB7A}" type="slidenum">
+              <a:rPr lang="ko-KR" altLang="en-US" smtClean="0"/>
+              <a:t>3</a:t>
+            </a:fld>
+            <a:endParaRPr lang="ko-KR" altLang="en-US" dirty="0"/>
+          </a:p>
+        </p:txBody>
+      </p:sp>
       <p:graphicFrame>
         <p:nvGraphicFramePr>
           <p:cNvPr id="3" name="Table 24">
             <a:extLst>
               <a:ext uri="{FF2B5EF4-FFF2-40B4-BE49-F238E27FC236}">
-                <a16:creationId xmlns:a16="http://schemas.microsoft.com/office/drawing/2014/main" id="{9EE54B7A-58D5-A265-CBE5-3B9A9BD8C0D6}"/>
+                <a16:creationId xmlns:a16="http://schemas.microsoft.com/office/drawing/2014/main" id="{F296F737-8C82-7794-102A-912EE34FC89B}"/>
               </a:ext>
             </a:extLst>
           </p:cNvPr>
           <p:cNvGraphicFramePr>
             <a:graphicFrameLocks noGrp="1"/>
           </p:cNvGraphicFramePr>
-          <p:nvPr>
-            <p:extLst>
-              <p:ext uri="{D42A27DB-BD31-4B8C-83A1-F6EECF244321}">
-                <p14:modId xmlns:p14="http://schemas.microsoft.com/office/powerpoint/2010/main" val="2563452925"/>
-              </p:ext>
-            </p:extLst>
-          </p:nvPr>
+          <p:nvPr/>
         </p:nvGraphicFramePr>
         <p:xfrm>
           <a:off x="1306216" y="1668340"/>
@@ -13804,7 +14130,7 @@
           <p:cNvPr id="7" name="내용 개체 틀 2">
             <a:extLst>
               <a:ext uri="{FF2B5EF4-FFF2-40B4-BE49-F238E27FC236}">
-                <a16:creationId xmlns:a16="http://schemas.microsoft.com/office/drawing/2014/main" id="{1085DB8A-F2FD-AB70-F0B6-F5E8612C16E3}"/>
+                <a16:creationId xmlns:a16="http://schemas.microsoft.com/office/drawing/2014/main" id="{C4AE4587-D9EE-3494-C321-6EC6B13EF63F}"/>
               </a:ext>
             </a:extLst>
           </p:cNvPr>
@@ -13851,7 +14177,7 @@
     </p:spTree>
     <p:extLst>
       <p:ext uri="{BB962C8B-B14F-4D97-AF65-F5344CB8AC3E}">
-        <p14:creationId xmlns:p14="http://schemas.microsoft.com/office/powerpoint/2010/main" val="217966962"/>
+        <p14:creationId xmlns:p14="http://schemas.microsoft.com/office/powerpoint/2010/main" val="2442842503"/>
       </p:ext>
     </p:extLst>
   </p:cSld>
@@ -13861,7 +14187,7 @@
 </p:sld>
 </file>
 
-<file path=ppt/slides/slide3.xml><?xml version="1.0" encoding="utf-8"?>
+<file path=ppt/slides/slide4.xml><?xml version="1.0" encoding="utf-8"?>
 <p:sld xmlns:a="http://schemas.openxmlformats.org/drawingml/2006/main" xmlns:r="http://schemas.openxmlformats.org/officeDocument/2006/relationships" xmlns:p="http://schemas.openxmlformats.org/presentationml/2006/main">
   <p:cSld>
     <p:spTree>
@@ -14081,7 +14407,7 @@
             <a:fld id="{9F4AF89A-28FA-47FA-B28F-9A9C6913CB7A}" type="slidenum">
               <a:rPr lang="ko-KR" altLang="en-US" smtClean="0"/>
               <a:pPr/>
-              <a:t>3</a:t>
+              <a:t>4</a:t>
             </a:fld>
             <a:endParaRPr lang="ko-KR" altLang="en-US" dirty="0"/>
           </a:p>
@@ -14100,7 +14426,7 @@
 </p:sld>
 </file>
 
-<file path=ppt/slides/slide4.xml><?xml version="1.0" encoding="utf-8"?>
+<file path=ppt/slides/slide5.xml><?xml version="1.0" encoding="utf-8"?>
 <p:sld xmlns:a="http://schemas.openxmlformats.org/drawingml/2006/main" xmlns:r="http://schemas.openxmlformats.org/officeDocument/2006/relationships" xmlns:p="http://schemas.openxmlformats.org/presentationml/2006/main">
   <p:cSld>
     <p:spTree>
@@ -14175,7 +14501,7 @@
           <a:p>
             <a:fld id="{9F4AF89A-28FA-47FA-B28F-9A9C6913CB7A}" type="slidenum">
               <a:rPr lang="ko-KR" altLang="en-US" smtClean="0"/>
-              <a:t>4</a:t>
+              <a:t>5</a:t>
             </a:fld>
             <a:endParaRPr lang="ko-KR" altLang="en-US" dirty="0"/>
           </a:p>
@@ -18559,7 +18885,7 @@
 </p:sld>
 </file>
 
-<file path=ppt/slides/slide5.xml><?xml version="1.0" encoding="utf-8"?>
+<file path=ppt/slides/slide6.xml><?xml version="1.0" encoding="utf-8"?>
 <p:sld xmlns:a="http://schemas.openxmlformats.org/drawingml/2006/main" xmlns:r="http://schemas.openxmlformats.org/officeDocument/2006/relationships" xmlns:p="http://schemas.openxmlformats.org/presentationml/2006/main">
   <p:cSld>
     <p:spTree>
@@ -18667,7 +18993,7 @@
             <a:fld id="{9F4AF89A-28FA-47FA-B28F-9A9C6913CB7A}" type="slidenum">
               <a:rPr lang="ko-KR" altLang="en-US" smtClean="0"/>
               <a:pPr/>
-              <a:t>5</a:t>
+              <a:t>6</a:t>
             </a:fld>
             <a:endParaRPr lang="ko-KR" altLang="en-US" dirty="0"/>
           </a:p>
@@ -18794,7 +19120,7 @@
 </p:sld>
 </file>
 
-<file path=ppt/slides/slide6.xml><?xml version="1.0" encoding="utf-8"?>
+<file path=ppt/slides/slide7.xml><?xml version="1.0" encoding="utf-8"?>
 <p:sld xmlns:a="http://schemas.openxmlformats.org/drawingml/2006/main" xmlns:r="http://schemas.openxmlformats.org/officeDocument/2006/relationships" xmlns:p="http://schemas.openxmlformats.org/presentationml/2006/main">
   <p:cSld>
     <p:spTree>

</xml_diff>